<commit_message>
Update A-Share Blast Lab / 2026-10-30 daily-15:05
</commit_message>
<xml_diff>
--- a/assets/多空阶段简报_2026-10-30.pptx
+++ b/assets/多空阶段简报_2026-10-30.pptx
@@ -340,16 +340,16 @@
                   <c:v>黄金白银</c:v>
                 </c:pt>
                 <c:pt idx="4">
-                  <c:v>互金证券</c:v>
+                  <c:v>半导体上游</c:v>
                 </c:pt>
                 <c:pt idx="5">
-                  <c:v>半导体上游</c:v>
+                  <c:v>电力</c:v>
                 </c:pt>
                 <c:pt idx="6">
                   <c:v>PCB</c:v>
                 </c:pt>
                 <c:pt idx="7">
-                  <c:v>电力</c:v>
+                  <c:v>互金证券</c:v>
                 </c:pt>
                 <c:pt idx="8">
                   <c:v>散热液冷</c:v>
@@ -364,7 +364,7 @@
                 <c:formatCode>General</c:formatCode>
                 <c:ptCount val="9"/>
                 <c:pt idx="0">
-                  <c:v>5</c:v>
+                  <c:v>6</c:v>
                 </c:pt>
                 <c:pt idx="1">
                   <c:v>0</c:v>
@@ -379,13 +379,13 @@
                   <c:v>0</c:v>
                 </c:pt>
                 <c:pt idx="5">
-                  <c:v>0</c:v>
+                  <c:v>1</c:v>
                 </c:pt>
                 <c:pt idx="6">
                   <c:v>1</c:v>
                 </c:pt>
                 <c:pt idx="7">
-                  <c:v>1</c:v>
+                  <c:v>0</c:v>
                 </c:pt>
                 <c:pt idx="8">
                   <c:v>0</c:v>
@@ -457,16 +457,16 @@
                   <c:v>黄金白银</c:v>
                 </c:pt>
                 <c:pt idx="4">
-                  <c:v>互金证券</c:v>
+                  <c:v>半导体上游</c:v>
                 </c:pt>
                 <c:pt idx="5">
-                  <c:v>半导体上游</c:v>
+                  <c:v>电力</c:v>
                 </c:pt>
                 <c:pt idx="6">
                   <c:v>PCB</c:v>
                 </c:pt>
                 <c:pt idx="7">
-                  <c:v>电力</c:v>
+                  <c:v>互金证券</c:v>
                 </c:pt>
                 <c:pt idx="8">
                   <c:v>散热液冷</c:v>
@@ -493,7 +493,7 @@
                   <c:v>0</c:v>
                 </c:pt>
                 <c:pt idx="4">
-                  <c:v>1</c:v>
+                  <c:v>0</c:v>
                 </c:pt>
                 <c:pt idx="5">
                   <c:v>0</c:v>
@@ -502,7 +502,7 @@
                   <c:v>0</c:v>
                 </c:pt>
                 <c:pt idx="7">
-                  <c:v>0</c:v>
+                  <c:v>1</c:v>
                 </c:pt>
                 <c:pt idx="8">
                   <c:v>0</c:v>
@@ -551,16 +551,16 @@
                   <c:v>黄金白银</c:v>
                 </c:pt>
                 <c:pt idx="4">
-                  <c:v>互金证券</c:v>
+                  <c:v>半导体上游</c:v>
                 </c:pt>
                 <c:pt idx="5">
-                  <c:v>半导体上游</c:v>
+                  <c:v>电力</c:v>
                 </c:pt>
                 <c:pt idx="6">
                   <c:v>PCB</c:v>
                 </c:pt>
                 <c:pt idx="7">
-                  <c:v>电力</c:v>
+                  <c:v>互金证券</c:v>
                 </c:pt>
                 <c:pt idx="8">
                   <c:v>散热液冷</c:v>
@@ -786,16 +786,16 @@
                   <c:v>黄金白银</c:v>
                 </c:pt>
                 <c:pt idx="4">
-                  <c:v>互金证券</c:v>
+                  <c:v>半导体上游</c:v>
                 </c:pt>
                 <c:pt idx="5">
-                  <c:v>半导体上游</c:v>
+                  <c:v>电力</c:v>
                 </c:pt>
                 <c:pt idx="6">
                   <c:v>PCB</c:v>
                 </c:pt>
                 <c:pt idx="7">
-                  <c:v>电力</c:v>
+                  <c:v>互金证券</c:v>
                 </c:pt>
                 <c:pt idx="8">
                   <c:v>散热液冷</c:v>
@@ -810,7 +810,7 @@
                 <c:formatCode>General</c:formatCode>
                 <c:ptCount val="9"/>
                 <c:pt idx="0">
-                  <c:v>4.4</c:v>
+                  <c:v>4.3</c:v>
                 </c:pt>
                 <c:pt idx="1">
                   <c:v>0.0</c:v>
@@ -822,16 +822,16 @@
                   <c:v>-4.5</c:v>
                 </c:pt>
                 <c:pt idx="4">
-                  <c:v>-4.9</c:v>
+                  <c:v>-6.1</c:v>
                 </c:pt>
                 <c:pt idx="5">
-                  <c:v>-6.1</c:v>
+                  <c:v>-6.2</c:v>
                 </c:pt>
                 <c:pt idx="6">
                   <c:v>-6.4</c:v>
                 </c:pt>
                 <c:pt idx="7">
-                  <c:v>-6.5</c:v>
+                  <c:v>-6.6</c:v>
                 </c:pt>
                 <c:pt idx="8">
                   <c:v>-7.5</c:v>
@@ -1351,7 +1351,7 @@
           <a:lstStyle/>
           <a:p>
             <a:r>
-              <a:t>当日共 18 个分组；改善 1、恶化 16。转多力度第一为 药，强度 4.38。最强低位转势候选为 无。</a:t>
+              <a:t>当日共 18 个分组；改善 1、恶化 16。转多力度第一为 药，强度 4.32。最强低位转势候选为 无。</a:t>
             </a:r>
           </a:p>
         </p:txBody>
@@ -1561,7 +1561,7 @@
           <a:lstStyle/>
           <a:p>
             <a:r>
-              <a:t>次日先看空转多转多能否继续扩散，再检查空转空转多的蓄势池。反向压力主要来自：机器人 转空 39 只｜AI应用 转空 39 只｜商业航天 转空 31 只｜半导体芯片 转空 19 只。</a:t>
+              <a:t>次日先看空转多转多能否继续扩散，再检查空转空转多的蓄势池。反向压力主要来自：AI应用 转空 40 只｜机器人 转空 39 只｜商业航天 转空 32 只｜半导体芯片 转空 20 只。</a:t>
             </a:r>
           </a:p>
         </p:txBody>
@@ -5603,7 +5603,7 @@
                 </a:solidFill>
                 <a:latin typeface="Microsoft YaHei"/>
               </a:rPr>
-              <a:t>强度 4.4</a:t>
+              <a:t>强度 4.3</a:t>
             </a:r>
           </a:p>
         </p:txBody>
@@ -6824,7 +6824,7 @@
                 </a:solidFill>
                 <a:latin typeface="Microsoft YaHei"/>
               </a:rPr>
-              <a:t>11 只｜多占比 18.2%</a:t>
+              <a:t>11 只｜多占比 18.0%</a:t>
             </a:r>
           </a:p>
         </p:txBody>
@@ -7421,7 +7421,7 @@
                 </a:solidFill>
                 <a:latin typeface="Microsoft YaHei"/>
               </a:rPr>
-              <a:t>药  ·  4.4</a:t>
+              <a:t>药  ·  4.3</a:t>
             </a:r>
           </a:p>
         </p:txBody>
@@ -7611,7 +7611,7 @@
                         </a:defRPr>
                       </a:pPr>
                       <a:r>
-                        <a:t>4.4</a:t>
+                        <a:t>4.3</a:t>
                       </a:r>
                     </a:p>
                   </a:txBody>
@@ -7979,7 +7979,7 @@
                         </a:defRPr>
                       </a:pPr>
                       <a:r>
-                        <a:t>互金证券</a:t>
+                        <a:t>半导体上游</a:t>
                       </a:r>
                     </a:p>
                   </a:txBody>
@@ -8003,7 +8003,7 @@
                         </a:defRPr>
                       </a:pPr>
                       <a:r>
-                        <a:t>-4.9</a:t>
+                        <a:t>-6.1</a:t>
                       </a:r>
                     </a:p>
                   </a:txBody>
@@ -8027,7 +8027,7 @@
                         </a:defRPr>
                       </a:pPr>
                       <a:r>
-                        <a:t>1只</a:t>
+                        <a:t>0只</a:t>
                       </a:r>
                     </a:p>
                   </a:txBody>
@@ -8077,7 +8077,7 @@
                         </a:defRPr>
                       </a:pPr>
                       <a:r>
-                        <a:t>半导体上游</a:t>
+                        <a:t>电力</a:t>
                       </a:r>
                     </a:p>
                   </a:txBody>
@@ -8101,7 +8101,7 @@
                         </a:defRPr>
                       </a:pPr>
                       <a:r>
-                        <a:t>-6.1</a:t>
+                        <a:t>-6.2</a:t>
                       </a:r>
                     </a:p>
                   </a:txBody>
@@ -8630,7 +8630,7 @@
                 </a:solidFill>
                 <a:latin typeface="Microsoft YaHei"/>
               </a:rPr>
-              <a:t>4.4 分</a:t>
+              <a:t>4.3 分</a:t>
             </a:r>
           </a:p>
         </p:txBody>
@@ -8672,7 +8672,7 @@
                 </a:solidFill>
                 <a:latin typeface="Microsoft YaHei"/>
               </a:rPr>
-              <a:t>空转多→多 4→11；反向转空 19 只</a:t>
+              <a:t>空转多→多 4→11；反向转空 20 只</a:t>
             </a:r>
           </a:p>
         </p:txBody>
@@ -8714,7 +8714,7 @@
                 </a:solidFill>
                 <a:latin typeface="Microsoft YaHei"/>
               </a:rPr>
-              <a:t>空转多→多 11 只｜空→空转多 5 只｜多占比 18.2%</a:t>
+              <a:t>空转多→多 11 只｜空→空转多 6 只｜多占比 18.0%</a:t>
             </a:r>
           </a:p>
         </p:txBody>
@@ -9555,7 +9555,7 @@
             <a:avLst/>
           </a:prstGeom>
           <a:solidFill>
-            <a:srgbClr val="E88B36"/>
+            <a:srgbClr val="F0B744"/>
           </a:solidFill>
           <a:ln>
             <a:noFill/>
@@ -9620,7 +9620,7 @@
                 </a:solidFill>
                 <a:latin typeface="Microsoft YaHei"/>
               </a:rPr>
-              <a:t>互金证券</a:t>
+              <a:t>半导体上游</a:t>
             </a:r>
           </a:p>
         </p:txBody>
@@ -9658,11 +9658,11 @@
             <a:r>
               <a:rPr sz="950" b="1" i="0">
                 <a:solidFill>
-                  <a:srgbClr val="E88B36"/>
+                  <a:srgbClr val="F0B744"/>
                 </a:solidFill>
                 <a:latin typeface="Microsoft YaHei"/>
               </a:rPr>
-              <a:t>-4.9 分</a:t>
+              <a:t>-6.1 分</a:t>
             </a:r>
           </a:p>
         </p:txBody>
@@ -9704,7 +9704,7 @@
                 </a:solidFill>
                 <a:latin typeface="Microsoft YaHei"/>
               </a:rPr>
-              <a:t>空转多→多 0→1；反向转空 5 只</a:t>
+              <a:t>反向转空 2 只</a:t>
             </a:r>
           </a:p>
         </p:txBody>
@@ -9746,7 +9746,7 @@
                 </a:solidFill>
                 <a:latin typeface="Microsoft YaHei"/>
               </a:rPr>
-              <a:t>空转多→多 1 只｜空→空转多 0 只｜多占比 1.6%</a:t>
+              <a:t>空转多→多 0 只｜空→空转多 0 只｜多占比 0.0%</a:t>
             </a:r>
           </a:p>
         </p:txBody>
@@ -9878,7 +9878,7 @@
                 </a:solidFill>
                 <a:latin typeface="Microsoft YaHei"/>
               </a:rPr>
-              <a:t>半导体上游</a:t>
+              <a:t>电力</a:t>
             </a:r>
           </a:p>
         </p:txBody>
@@ -9920,7 +9920,7 @@
                 </a:solidFill>
                 <a:latin typeface="Microsoft YaHei"/>
               </a:rPr>
-              <a:t>-6.1 分</a:t>
+              <a:t>-6.2 分</a:t>
             </a:r>
           </a:p>
         </p:txBody>
@@ -9962,7 +9962,7 @@
                 </a:solidFill>
                 <a:latin typeface="Microsoft YaHei"/>
               </a:rPr>
-              <a:t>反向转空 2 只</a:t>
+              <a:t>空→空转多蓄势 1 只；反向转空 2 只</a:t>
             </a:r>
           </a:p>
         </p:txBody>
@@ -10004,7 +10004,7 @@
                 </a:solidFill>
                 <a:latin typeface="Microsoft YaHei"/>
               </a:rPr>
-              <a:t>空转多→多 0 只｜空→空转多 0 只｜多占比 0.0%</a:t>
+              <a:t>空转多→多 0 只｜空→空转多 1 只｜多占比 3.1%</a:t>
             </a:r>
           </a:p>
         </p:txBody>
@@ -10133,7 +10133,7 @@
                 </a:solidFill>
                 <a:latin typeface="Microsoft YaHei"/>
               </a:rPr>
-              <a:t>机器人 转空 39 只｜AI应用 转空 39 只｜商业航天 转空 31 只｜半导体芯片 转空 19 只</a:t>
+              <a:t>AI应用 转空 40 只｜机器人 转空 39 只｜商业航天 转空 32 只｜半导体芯片 转空 20 只</a:t>
             </a:r>
           </a:p>
         </p:txBody>

</xml_diff>